<commit_message>
docs(examples): rewrite charts.sh master showcase + tables.sh pptx to high-level API
charts.sh / charts.py: the 8-chart master showcase now builds via the high-level
`add --type chart` command (chartType + cell dataRange or inline data + styling:
combo secondary axis, 3D view, scatter trendline, exploded 3D pie, stock OHLC
up/down bars, filled radar, multi-ring doughnut) instead of hand-authored chart
XML. Only Chart 5 (bubble) stays on raw-set — the high-level command can't map a
dataRange to a single x/y/size series. charts.md rewritten from a TODO stub into
an annotated guide. (The redundant charts/charts-demo four-set was already
removed; README now points to the charts/ per-type subdirectory.)

tables.sh: the PowerPoint report's title and data-table slides now use
`add slide/shape/table` + `set background` + per-cell `set` instead of raw-set
replacing the whole /p:sld. Slide 3 was already high-level.
</commit_message>
<xml_diff>
--- a/examples/word/tables.pptx
+++ b/examples/word/tables.pptx
@@ -5,9 +5,9 @@
     <p:sldMasterId xmlns:r="http://schemas.openxmlformats.org/officeDocument/2006/relationships" id="2147483648" r:id="rId1"/>
   </p:sldMasterIdLst>
   <p:sldIdLst>
-    <p:sldId id="256" r:id="Rf767efc9db5349b1"/>
-    <p:sldId id="257" r:id="Rc70f4b162de34128"/>
-    <p:sldId id="258" r:id="Reca210099e0340b2"/>
+    <p:sldId id="256" r:id="Re93f878004fa4c6b"/>
+    <p:sldId id="257" r:id="Red377f828a7f4cde"/>
+    <p:sldId id="258" r:id="R0bdcebc6ad1143d9"/>
   </p:sldIdLst>
   <p:sldSz cx="12192000" cy="6858000"/>
   <p:notesSz cx="6858000" cy="9144000"/>
@@ -282,7 +282,7 @@
 </file>
 
 <file path=ppt/slideMasters/slideMaster1.xml><?xml version="1.0" encoding="utf-8"?>
-<p:sldMaster xmlns:p="http://schemas.openxmlformats.org/presentationml/2006/main">
+<p:sldMaster xmlns:r="http://schemas.openxmlformats.org/officeDocument/2006/relationships" xmlns:p="http://schemas.openxmlformats.org/presentationml/2006/main">
   <p:cSld>
     <p:spTree>
       <p:nvGrpSpPr>
@@ -312,7 +312,6 @@
         <a:solidFill xmlns:a="http://schemas.openxmlformats.org/drawingml/2006/main">
           <a:srgbClr val="1F3864"/>
         </a:solidFill>
-        <a:effectLst xmlns:a="http://schemas.openxmlformats.org/drawingml/2006/main"/>
       </p:bgPr>
     </p:bg>
     <p:spTree>
@@ -321,18 +320,11 @@
         <p:cNvGrpSpPr/>
         <p:nvPr/>
       </p:nvGrpSpPr>
-      <p:grpSpPr>
-        <a:xfrm xmlns:a="http://schemas.openxmlformats.org/drawingml/2006/main">
-          <a:off x="0" y="0"/>
-          <a:ext cx="0" cy="0"/>
-          <a:chOff x="0" y="0"/>
-          <a:chExt cx="0" cy="0"/>
-        </a:xfrm>
-      </p:grpSpPr>
-      <p:sp>
-        <p:nvSpPr>
-          <p:cNvPr id="2" name="Title"/>
-          <p:cNvSpPr/>
+      <p:grpSpPr/>
+      <p:sp>
+        <p:nvSpPr>
+          <p:cNvPr id="100000" name="TextBox 1"/>
+          <p:cNvSpPr txBox="1"/>
           <p:nvPr/>
         </p:nvSpPr>
         <p:spPr>
@@ -343,7 +335,6 @@
           <a:prstGeom xmlns:a="http://schemas.openxmlformats.org/drawingml/2006/main" prst="rect">
             <a:avLst/>
           </a:prstGeom>
-          <a:noFill xmlns:a="http://schemas.openxmlformats.org/drawingml/2006/main"/>
         </p:spPr>
         <p:txBody>
           <a:bodyPr xmlns:a="http://schemas.openxmlformats.org/drawingml/2006/main" anchor="ctr"/>
@@ -351,7 +342,7 @@
           <a:p xmlns:a="http://schemas.openxmlformats.org/drawingml/2006/main">
             <a:pPr algn="ctr"/>
             <a:r>
-              <a:rPr lang="en-US" sz="4000" b="1" dirty="0">
+              <a:rPr lang="en-US" sz="4000" b="1">
                 <a:solidFill>
                   <a:srgbClr val="FFFFFF"/>
                 </a:solidFill>
@@ -363,8 +354,8 @@
       </p:sp>
       <p:sp>
         <p:nvSpPr>
-          <p:cNvPr id="3" name="Subtitle"/>
-          <p:cNvSpPr/>
+          <p:cNvPr id="100001" name="TextBox 2"/>
+          <p:cNvSpPr txBox="1"/>
           <p:nvPr/>
         </p:nvSpPr>
         <p:spPr>
@@ -375,7 +366,6 @@
           <a:prstGeom xmlns:a="http://schemas.openxmlformats.org/drawingml/2006/main" prst="rect">
             <a:avLst/>
           </a:prstGeom>
-          <a:noFill xmlns:a="http://schemas.openxmlformats.org/drawingml/2006/main"/>
         </p:spPr>
         <p:txBody>
           <a:bodyPr xmlns:a="http://schemas.openxmlformats.org/drawingml/2006/main" anchor="ctr"/>
@@ -383,7 +373,7 @@
           <a:p xmlns:a="http://schemas.openxmlformats.org/drawingml/2006/main">
             <a:pPr algn="ctr"/>
             <a:r>
-              <a:rPr lang="en-US" sz="2000" dirty="0">
+              <a:rPr lang="en-US" sz="2000">
                 <a:solidFill>
                   <a:srgbClr val="BDD7EE"/>
                 </a:solidFill>
@@ -407,18 +397,11 @@
         <p:cNvGrpSpPr/>
         <p:nvPr/>
       </p:nvGrpSpPr>
-      <p:grpSpPr>
-        <a:xfrm xmlns:a="http://schemas.openxmlformats.org/drawingml/2006/main">
-          <a:off x="0" y="0"/>
-          <a:ext cx="0" cy="0"/>
-          <a:chOff x="0" y="0"/>
-          <a:chExt cx="0" cy="0"/>
-        </a:xfrm>
-      </p:grpSpPr>
-      <p:sp>
-        <p:nvSpPr>
-          <p:cNvPr id="2" name="Title"/>
-          <p:cNvSpPr/>
+      <p:grpSpPr/>
+      <p:sp>
+        <p:nvSpPr>
+          <p:cNvPr id="100002" name="TextBox 1"/>
+          <p:cNvSpPr txBox="1"/>
           <p:nvPr/>
         </p:nvSpPr>
         <p:spPr>
@@ -429,15 +412,13 @@
           <a:prstGeom xmlns:a="http://schemas.openxmlformats.org/drawingml/2006/main" prst="rect">
             <a:avLst/>
           </a:prstGeom>
-          <a:noFill xmlns:a="http://schemas.openxmlformats.org/drawingml/2006/main"/>
-        </p:spPr>
-        <p:txBody>
-          <a:bodyPr xmlns:a="http://schemas.openxmlformats.org/drawingml/2006/main"/>
-          <a:lstStyle xmlns:a="http://schemas.openxmlformats.org/drawingml/2006/main"/>
-          <a:p xmlns:a="http://schemas.openxmlformats.org/drawingml/2006/main">
-            <a:pPr algn="l"/>
+        </p:spPr>
+        <p:txBody>
+          <a:bodyPr xmlns:a="http://schemas.openxmlformats.org/drawingml/2006/main"/>
+          <a:lstStyle xmlns:a="http://schemas.openxmlformats.org/drawingml/2006/main"/>
+          <a:p xmlns:a="http://schemas.openxmlformats.org/drawingml/2006/main">
             <a:r>
-              <a:rPr lang="en-US" sz="2800" b="1" dirty="0">
+              <a:rPr lang="en-US" sz="2800" b="1">
                 <a:solidFill>
                   <a:srgbClr val="1F3864"/>
                 </a:solidFill>
@@ -449,10 +430,8 @@
       </p:sp>
       <p:graphicFrame>
         <p:nvGraphicFramePr>
-          <p:cNvPr id="4" name="Table"/>
-          <p:cNvGraphicFramePr>
-            <a:graphicFrameLocks xmlns:a="http://schemas.openxmlformats.org/drawingml/2006/main" noGrp="1"/>
-          </p:cNvGraphicFramePr>
+          <p:cNvPr id="100003" name="Table 1"/>
+          <p:cNvGraphicFramePr/>
           <p:nvPr/>
         </p:nvGraphicFramePr>
         <p:xfrm>
@@ -470,15 +449,15 @@
                 <a:gridCol w="2238400"/>
                 <a:gridCol w="2238400"/>
               </a:tblGrid>
-              <a:tr h="700000">
-                <a:tc>
-                  <a:txBody>
-                    <a:bodyPr/>
-                    <a:lstStyle/>
-                    <a:p>
-                      <a:pPr algn="ctr"/>
-                      <a:r>
-                        <a:rPr lang="en-US" sz="1600" b="1" dirty="0">
+              <a:tr h="750000">
+                <a:tc>
+                  <a:txBody>
+                    <a:bodyPr/>
+                    <a:lstStyle/>
+                    <a:p>
+                      <a:pPr algn="ctr"/>
+                      <a:r>
+                        <a:rPr lang="en-US" b="1">
                           <a:solidFill>
                             <a:srgbClr val="FFFFFF"/>
                           </a:solidFill>
@@ -500,7 +479,7 @@
                     <a:p>
                       <a:pPr algn="ctr"/>
                       <a:r>
-                        <a:rPr lang="en-US" sz="1600" b="1" dirty="0">
+                        <a:rPr lang="en-US" b="1">
                           <a:solidFill>
                             <a:srgbClr val="FFFFFF"/>
                           </a:solidFill>
@@ -522,7 +501,7 @@
                     <a:p>
                       <a:pPr algn="ctr"/>
                       <a:r>
-                        <a:rPr lang="en-US" sz="1600" b="1" dirty="0">
+                        <a:rPr lang="en-US" b="1">
                           <a:solidFill>
                             <a:srgbClr val="FFFFFF"/>
                           </a:solidFill>
@@ -544,7 +523,7 @@
                     <a:p>
                       <a:pPr algn="ctr"/>
                       <a:r>
-                        <a:rPr lang="en-US" sz="1600" b="1" dirty="0">
+                        <a:rPr lang="en-US" b="1">
                           <a:solidFill>
                             <a:srgbClr val="FFFFFF"/>
                           </a:solidFill>
@@ -566,7 +545,7 @@
                     <a:p>
                       <a:pPr algn="ctr"/>
                       <a:r>
-                        <a:rPr lang="en-US" sz="1600" b="1" dirty="0">
+                        <a:rPr lang="en-US" b="1">
                           <a:solidFill>
                             <a:srgbClr val="FFFFFF"/>
                           </a:solidFill>
@@ -582,15 +561,15 @@
                   </a:tcPr>
                 </a:tc>
               </a:tr>
-              <a:tr h="700000">
-                <a:tc>
-                  <a:txBody>
-                    <a:bodyPr/>
-                    <a:lstStyle/>
-                    <a:p>
-                      <a:pPr algn="ctr"/>
-                      <a:r>
-                        <a:rPr lang="en-US" sz="1400" dirty="0"/>
+              <a:tr h="750000">
+                <a:tc>
+                  <a:txBody>
+                    <a:bodyPr/>
+                    <a:lstStyle/>
+                    <a:p>
+                      <a:pPr algn="ctr"/>
+                      <a:r>
+                        <a:rPr lang="en-US"/>
                         <a:t>Engineering</a:t>
                       </a:r>
                     </a:p>
@@ -608,7 +587,7 @@
                     <a:p>
                       <a:pPr algn="ctr"/>
                       <a:r>
-                        <a:rPr lang="en-US" sz="1400" dirty="0"/>
+                        <a:rPr lang="en-US"/>
                         <a:t>128,000</a:t>
                       </a:r>
                     </a:p>
@@ -622,7 +601,7 @@
                     <a:p>
                       <a:pPr algn="ctr"/>
                       <a:r>
-                        <a:rPr lang="en-US" sz="1400" dirty="0"/>
+                        <a:rPr lang="en-US"/>
                         <a:t>156,000</a:t>
                       </a:r>
                     </a:p>
@@ -636,7 +615,7 @@
                     <a:p>
                       <a:pPr algn="ctr"/>
                       <a:r>
-                        <a:rPr lang="en-US" sz="1400" dirty="0"/>
+                        <a:rPr lang="en-US"/>
                         <a:t>189,000</a:t>
                       </a:r>
                     </a:p>
@@ -650,7 +629,7 @@
                     <a:p>
                       <a:pPr algn="ctr"/>
                       <a:r>
-                        <a:rPr lang="en-US" sz="1400" dirty="0"/>
+                        <a:rPr lang="en-US"/>
                         <a:t>210,000</a:t>
                       </a:r>
                     </a:p>
@@ -658,15 +637,15 @@
                   <a:tcPr/>
                 </a:tc>
               </a:tr>
-              <a:tr h="700000">
-                <a:tc>
-                  <a:txBody>
-                    <a:bodyPr/>
-                    <a:lstStyle/>
-                    <a:p>
-                      <a:pPr algn="ctr"/>
-                      <a:r>
-                        <a:rPr lang="en-US" sz="1400" dirty="0"/>
+              <a:tr h="750000">
+                <a:tc>
+                  <a:txBody>
+                    <a:bodyPr/>
+                    <a:lstStyle/>
+                    <a:p>
+                      <a:pPr algn="ctr"/>
+                      <a:r>
+                        <a:rPr lang="en-US"/>
                         <a:t>Marketing</a:t>
                       </a:r>
                     </a:p>
@@ -684,7 +663,7 @@
                     <a:p>
                       <a:pPr algn="ctr"/>
                       <a:r>
-                        <a:rPr lang="en-US" sz="1400" dirty="0"/>
+                        <a:rPr lang="en-US"/>
                         <a:t>95,000</a:t>
                       </a:r>
                     </a:p>
@@ -698,7 +677,7 @@
                     <a:p>
                       <a:pPr algn="ctr"/>
                       <a:r>
-                        <a:rPr lang="en-US" sz="1400" dirty="0"/>
+                        <a:rPr lang="en-US"/>
                         <a:t>112,000</a:t>
                       </a:r>
                     </a:p>
@@ -712,7 +691,7 @@
                     <a:p>
                       <a:pPr algn="ctr"/>
                       <a:r>
-                        <a:rPr lang="en-US" sz="1400" dirty="0"/>
+                        <a:rPr lang="en-US"/>
                         <a:t>138,000</a:t>
                       </a:r>
                     </a:p>
@@ -726,7 +705,7 @@
                     <a:p>
                       <a:pPr algn="ctr"/>
                       <a:r>
-                        <a:rPr lang="en-US" sz="1400" dirty="0"/>
+                        <a:rPr lang="en-US"/>
                         <a:t>165,000</a:t>
                       </a:r>
                     </a:p>
@@ -734,15 +713,15 @@
                   <a:tcPr/>
                 </a:tc>
               </a:tr>
-              <a:tr h="700000">
-                <a:tc>
-                  <a:txBody>
-                    <a:bodyPr/>
-                    <a:lstStyle/>
-                    <a:p>
-                      <a:pPr algn="ctr"/>
-                      <a:r>
-                        <a:rPr lang="en-US" sz="1400" dirty="0"/>
+              <a:tr h="750000">
+                <a:tc>
+                  <a:txBody>
+                    <a:bodyPr/>
+                    <a:lstStyle/>
+                    <a:p>
+                      <a:pPr algn="ctr"/>
+                      <a:r>
+                        <a:rPr lang="en-US"/>
                         <a:t>Operations</a:t>
                       </a:r>
                     </a:p>
@@ -760,7 +739,7 @@
                     <a:p>
                       <a:pPr algn="ctr"/>
                       <a:r>
-                        <a:rPr lang="en-US" sz="1400" dirty="0"/>
+                        <a:rPr lang="en-US"/>
                         <a:t>76,000</a:t>
                       </a:r>
                     </a:p>
@@ -774,7 +753,7 @@
                     <a:p>
                       <a:pPr algn="ctr"/>
                       <a:r>
-                        <a:rPr lang="en-US" sz="1400" dirty="0"/>
+                        <a:rPr lang="en-US"/>
                         <a:t>89,000</a:t>
                       </a:r>
                     </a:p>
@@ -788,7 +767,7 @@
                     <a:p>
                       <a:pPr algn="ctr"/>
                       <a:r>
-                        <a:rPr lang="en-US" sz="1400" dirty="0"/>
+                        <a:rPr lang="en-US"/>
                         <a:t>102,000</a:t>
                       </a:r>
                     </a:p>
@@ -802,7 +781,7 @@
                     <a:p>
                       <a:pPr algn="ctr"/>
                       <a:r>
-                        <a:rPr lang="en-US" sz="1400" dirty="0"/>
+                        <a:rPr lang="en-US"/>
                         <a:t>118,000</a:t>
                       </a:r>
                     </a:p>
@@ -810,15 +789,15 @@
                   <a:tcPr/>
                 </a:tc>
               </a:tr>
-              <a:tr h="700000">
-                <a:tc>
-                  <a:txBody>
-                    <a:bodyPr/>
-                    <a:lstStyle/>
-                    <a:p>
-                      <a:pPr algn="ctr"/>
-                      <a:r>
-                        <a:rPr lang="en-US" sz="1400" dirty="0"/>
+              <a:tr h="750000">
+                <a:tc>
+                  <a:txBody>
+                    <a:bodyPr/>
+                    <a:lstStyle/>
+                    <a:p>
+                      <a:pPr algn="ctr"/>
+                      <a:r>
+                        <a:rPr lang="en-US"/>
                         <a:t>Sales</a:t>
                       </a:r>
                     </a:p>
@@ -836,7 +815,7 @@
                     <a:p>
                       <a:pPr algn="ctr"/>
                       <a:r>
-                        <a:rPr lang="en-US" sz="1400" dirty="0"/>
+                        <a:rPr lang="en-US"/>
                         <a:t>230,000</a:t>
                       </a:r>
                     </a:p>
@@ -850,7 +829,7 @@
                     <a:p>
                       <a:pPr algn="ctr"/>
                       <a:r>
-                        <a:rPr lang="en-US" sz="1400" dirty="0"/>
+                        <a:rPr lang="en-US"/>
                         <a:t>275,000</a:t>
                       </a:r>
                     </a:p>
@@ -864,7 +843,7 @@
                     <a:p>
                       <a:pPr algn="ctr"/>
                       <a:r>
-                        <a:rPr lang="en-US" sz="1400" dirty="0"/>
+                        <a:rPr lang="en-US"/>
                         <a:t>310,000</a:t>
                       </a:r>
                     </a:p>
@@ -878,7 +857,7 @@
                     <a:p>
                       <a:pPr algn="ctr"/>
                       <a:r>
-                        <a:rPr lang="en-US" sz="1400" dirty="0"/>
+                        <a:rPr lang="en-US"/>
                         <a:t>356,000</a:t>
                       </a:r>
                     </a:p>
@@ -886,15 +865,15 @@
                   <a:tcPr/>
                 </a:tc>
               </a:tr>
-              <a:tr h="700000">
-                <a:tc>
-                  <a:txBody>
-                    <a:bodyPr/>
-                    <a:lstStyle/>
-                    <a:p>
-                      <a:pPr algn="ctr"/>
-                      <a:r>
-                        <a:rPr lang="en-US" sz="1400" dirty="0"/>
+              <a:tr h="750000">
+                <a:tc>
+                  <a:txBody>
+                    <a:bodyPr/>
+                    <a:lstStyle/>
+                    <a:p>
+                      <a:pPr algn="ctr"/>
+                      <a:r>
+                        <a:rPr lang="en-US"/>
                         <a:t>HR</a:t>
                       </a:r>
                     </a:p>
@@ -912,7 +891,7 @@
                     <a:p>
                       <a:pPr algn="ctr"/>
                       <a:r>
-                        <a:rPr lang="en-US" sz="1400" dirty="0"/>
+                        <a:rPr lang="en-US"/>
                         <a:t>45,000</a:t>
                       </a:r>
                     </a:p>
@@ -926,7 +905,7 @@
                     <a:p>
                       <a:pPr algn="ctr"/>
                       <a:r>
-                        <a:rPr lang="en-US" sz="1400" dirty="0"/>
+                        <a:rPr lang="en-US"/>
                         <a:t>48,000</a:t>
                       </a:r>
                     </a:p>
@@ -940,7 +919,7 @@
                     <a:p>
                       <a:pPr algn="ctr"/>
                       <a:r>
-                        <a:rPr lang="en-US" sz="1400" dirty="0"/>
+                        <a:rPr lang="en-US"/>
                         <a:t>52,000</a:t>
                       </a:r>
                     </a:p>
@@ -954,7 +933,7 @@
                     <a:p>
                       <a:pPr algn="ctr"/>
                       <a:r>
-                        <a:rPr lang="en-US" sz="1400" dirty="0"/>
+                        <a:rPr lang="en-US"/>
                         <a:t>55,000</a:t>
                       </a:r>
                     </a:p>
@@ -983,7 +962,7 @@
       <p:grpSpPr/>
       <p:sp>
         <p:nvSpPr>
-          <p:cNvPr id="100000" name="TextBox 1"/>
+          <p:cNvPr id="100004" name="TextBox 1"/>
           <p:cNvSpPr txBox="1"/>
           <p:nvPr/>
         </p:nvSpPr>
@@ -1009,7 +988,7 @@
       </p:sp>
       <p:sp>
         <p:nvSpPr>
-          <p:cNvPr id="100001" name="TextBox 2"/>
+          <p:cNvPr id="100005" name="TextBox 2"/>
           <p:cNvSpPr txBox="1"/>
           <p:nvPr/>
         </p:nvSpPr>
@@ -1035,7 +1014,7 @@
       </p:sp>
       <p:sp>
         <p:nvSpPr>
-          <p:cNvPr id="100002" name="TextBox 3"/>
+          <p:cNvPr id="100006" name="TextBox 3"/>
           <p:cNvSpPr txBox="1"/>
           <p:nvPr/>
         </p:nvSpPr>
@@ -1061,7 +1040,7 @@
       </p:sp>
       <p:sp>
         <p:nvSpPr>
-          <p:cNvPr id="100003" name="TextBox 4"/>
+          <p:cNvPr id="100007" name="TextBox 4"/>
           <p:cNvSpPr txBox="1"/>
           <p:nvPr/>
         </p:nvSpPr>
@@ -1087,7 +1066,7 @@
       </p:sp>
       <p:sp>
         <p:nvSpPr>
-          <p:cNvPr id="100004" name="TextBox 5"/>
+          <p:cNvPr id="100008" name="TextBox 5"/>
           <p:cNvSpPr txBox="1"/>
           <p:nvPr/>
         </p:nvSpPr>
@@ -1113,7 +1092,7 @@
       </p:sp>
       <p:sp>
         <p:nvSpPr>
-          <p:cNvPr id="100005" name="TextBox 6"/>
+          <p:cNvPr id="100009" name="TextBox 6"/>
           <p:cNvSpPr txBox="1"/>
           <p:nvPr/>
         </p:nvSpPr>

</xml_diff>